<commit_message>
🤖 Weekly content brief — 2026-03-24
</commit_message>
<xml_diff>
--- a/automation/output/2026-03-24-week13-topic3-carousel.pptx
+++ b/automation/output/2026-03-24-week13-topic3-carousel.pptx
@@ -1672,12 +1672,20 @@
           </a:p>
         </p:txBody>
       </p:sp>
-      <p:sp>
-        <p:nvSpPr>
-          <p:cNvPr id="6" name="Shape 4"/>
-          <p:cNvSpPr/>
-          <p:nvPr/>
-        </p:nvSpPr>
+      <p:pic>
+        <p:nvPicPr>
+          <p:cNvPr id="6" name="Image 0" descr="preencoded.png">    </p:cNvPr>
+          <p:cNvPicPr>
+            <a:picLocks noChangeAspect="1"/>
+          </p:cNvPicPr>
+          <p:nvPr/>
+        </p:nvPicPr>
+        <p:blipFill>
+          <a:blip r:embed="rId1"/>
+          <a:stretch>
+            <a:fillRect/>
+          </a:stretch>
+        </p:blipFill>
         <p:spPr>
           <a:xfrm>
             <a:off x="182880" y="1828800"/>
@@ -1686,8 +1694,26 @@
           <a:prstGeom prst="rect">
             <a:avLst/>
           </a:prstGeom>
-          <a:solidFill>
-            <a:srgbClr val="5C5915"/>
+        </p:spPr>
+      </p:pic>
+      <p:sp>
+        <p:nvSpPr>
+          <p:cNvPr id="7" name="Shape 4"/>
+          <p:cNvSpPr/>
+          <p:nvPr/>
+        </p:nvSpPr>
+        <p:spPr>
+          <a:xfrm>
+            <a:off x="182880" y="1828800"/>
+            <a:ext cx="2395728" cy="2011680"/>
+          </a:xfrm>
+          <a:prstGeom prst="rect">
+            <a:avLst/>
+          </a:prstGeom>
+          <a:solidFill>
+            <a:srgbClr val="000000">
+              <a:alpha val="65000"/>
+            </a:srgbClr>
           </a:solidFill>
           <a:ln w="12700">
             <a:solidFill>
@@ -1699,7 +1725,7 @@
       </p:sp>
       <p:sp>
         <p:nvSpPr>
-          <p:cNvPr id="7" name="Text 5"/>
+          <p:cNvPr id="8" name="Text 5"/>
           <p:cNvSpPr/>
           <p:nvPr/>
         </p:nvSpPr>
@@ -1738,7 +1764,7 @@
       </p:sp>
       <p:sp>
         <p:nvSpPr>
-          <p:cNvPr id="8" name="Shape 6"/>
+          <p:cNvPr id="9" name="Shape 6"/>
           <p:cNvSpPr/>
           <p:nvPr/>
         </p:nvSpPr>
@@ -1763,7 +1789,7 @@
       </p:sp>
       <p:sp>
         <p:nvSpPr>
-          <p:cNvPr id="9" name="Text 7"/>
+          <p:cNvPr id="10" name="Text 7"/>
           <p:cNvSpPr/>
           <p:nvPr/>
         </p:nvSpPr>
@@ -1800,12 +1826,20 @@
           </a:p>
         </p:txBody>
       </p:sp>
-      <p:sp>
-        <p:nvSpPr>
-          <p:cNvPr id="10" name="Shape 8"/>
-          <p:cNvSpPr/>
-          <p:nvPr/>
-        </p:nvSpPr>
+      <p:pic>
+        <p:nvPicPr>
+          <p:cNvPr id="11" name="Image 1" descr="preencoded.png">    </p:cNvPr>
+          <p:cNvPicPr>
+            <a:picLocks noChangeAspect="1"/>
+          </p:cNvPicPr>
+          <p:nvPr/>
+        </p:nvPicPr>
+        <p:blipFill>
+          <a:blip r:embed="rId2"/>
+          <a:stretch>
+            <a:fillRect/>
+          </a:stretch>
+        </p:blipFill>
         <p:spPr>
           <a:xfrm>
             <a:off x="2907792" y="1828800"/>
@@ -1814,8 +1848,26 @@
           <a:prstGeom prst="rect">
             <a:avLst/>
           </a:prstGeom>
-          <a:solidFill>
-            <a:srgbClr val="5C5915"/>
+        </p:spPr>
+      </p:pic>
+      <p:sp>
+        <p:nvSpPr>
+          <p:cNvPr id="12" name="Shape 8"/>
+          <p:cNvSpPr/>
+          <p:nvPr/>
+        </p:nvSpPr>
+        <p:spPr>
+          <a:xfrm>
+            <a:off x="2907792" y="1828800"/>
+            <a:ext cx="2395728" cy="2011680"/>
+          </a:xfrm>
+          <a:prstGeom prst="rect">
+            <a:avLst/>
+          </a:prstGeom>
+          <a:solidFill>
+            <a:srgbClr val="000000">
+              <a:alpha val="65000"/>
+            </a:srgbClr>
           </a:solidFill>
           <a:ln w="12700">
             <a:solidFill>
@@ -1827,7 +1879,7 @@
       </p:sp>
       <p:sp>
         <p:nvSpPr>
-          <p:cNvPr id="11" name="Text 9"/>
+          <p:cNvPr id="13" name="Text 9"/>
           <p:cNvSpPr/>
           <p:nvPr/>
         </p:nvSpPr>
@@ -1866,7 +1918,7 @@
       </p:sp>
       <p:sp>
         <p:nvSpPr>
-          <p:cNvPr id="12" name="Shape 10"/>
+          <p:cNvPr id="14" name="Shape 10"/>
           <p:cNvSpPr/>
           <p:nvPr/>
         </p:nvSpPr>
@@ -1891,7 +1943,7 @@
       </p:sp>
       <p:sp>
         <p:nvSpPr>
-          <p:cNvPr id="13" name="Text 11"/>
+          <p:cNvPr id="15" name="Text 11"/>
           <p:cNvSpPr/>
           <p:nvPr/>
         </p:nvSpPr>
@@ -1922,18 +1974,26 @@
                 <a:ea typeface="Arial" pitchFamily="34" charset="-122"/>
                 <a:cs typeface="Arial" pitchFamily="34" charset="-120"/>
               </a:rPr>
-              <a:t>17 kcal · 1g fiber per 100g</a:t>
+              <a:t>17 kcal · 1g fiber per cup</a:t>
             </a:r>
             <a:endParaRPr lang="en-US" sz="1100" dirty="0"/>
           </a:p>
         </p:txBody>
       </p:sp>
-      <p:sp>
-        <p:nvSpPr>
-          <p:cNvPr id="14" name="Shape 12"/>
-          <p:cNvSpPr/>
-          <p:nvPr/>
-        </p:nvSpPr>
+      <p:pic>
+        <p:nvPicPr>
+          <p:cNvPr id="16" name="Image 2" descr="preencoded.png">    </p:cNvPr>
+          <p:cNvPicPr>
+            <a:picLocks noChangeAspect="1"/>
+          </p:cNvPicPr>
+          <p:nvPr/>
+        </p:nvPicPr>
+        <p:blipFill>
+          <a:blip r:embed="rId3"/>
+          <a:stretch>
+            <a:fillRect/>
+          </a:stretch>
+        </p:blipFill>
         <p:spPr>
           <a:xfrm>
             <a:off x="182880" y="4005072"/>
@@ -1942,8 +2002,26 @@
           <a:prstGeom prst="rect">
             <a:avLst/>
           </a:prstGeom>
-          <a:solidFill>
-            <a:srgbClr val="5C5915"/>
+        </p:spPr>
+      </p:pic>
+      <p:sp>
+        <p:nvSpPr>
+          <p:cNvPr id="17" name="Shape 12"/>
+          <p:cNvSpPr/>
+          <p:nvPr/>
+        </p:nvSpPr>
+        <p:spPr>
+          <a:xfrm>
+            <a:off x="182880" y="4005072"/>
+            <a:ext cx="2395728" cy="2011680"/>
+          </a:xfrm>
+          <a:prstGeom prst="rect">
+            <a:avLst/>
+          </a:prstGeom>
+          <a:solidFill>
+            <a:srgbClr val="000000">
+              <a:alpha val="65000"/>
+            </a:srgbClr>
           </a:solidFill>
           <a:ln w="12700">
             <a:solidFill>
@@ -1955,13 +2033,167 @@
       </p:sp>
       <p:sp>
         <p:nvSpPr>
-          <p:cNvPr id="15" name="Text 13"/>
+          <p:cNvPr id="18" name="Text 13"/>
           <p:cNvSpPr/>
           <p:nvPr/>
         </p:nvSpPr>
         <p:spPr>
           <a:xfrm>
             <a:off x="320040" y="4169664"/>
+            <a:ext cx="2121408" cy="594360"/>
+          </a:xfrm>
+          <a:prstGeom prst="rect">
+            <a:avLst/>
+          </a:prstGeom>
+          <a:noFill/>
+          <a:ln/>
+        </p:spPr>
+        <p:txBody>
+          <a:bodyPr wrap="square" rtlCol="0" anchor="ctr"/>
+          <a:lstStyle/>
+          <a:p>
+            <a:pPr indent="0" marL="0">
+              <a:buNone/>
+            </a:pPr>
+            <a:r>
+              <a:rPr lang="en-US" sz="1400" b="1" dirty="0">
+                <a:solidFill>
+                  <a:srgbClr val="FFFFFF"/>
+                </a:solidFill>
+                <a:latin typeface="Arial" pitchFamily="34" charset="0"/>
+                <a:ea typeface="Arial" pitchFamily="34" charset="-122"/>
+                <a:cs typeface="Arial" pitchFamily="34" charset="-120"/>
+              </a:rPr>
+              <a:t>Cabbage</a:t>
+            </a:r>
+            <a:endParaRPr lang="en-US" sz="1400" dirty="0"/>
+          </a:p>
+        </p:txBody>
+      </p:sp>
+      <p:sp>
+        <p:nvSpPr>
+          <p:cNvPr id="19" name="Shape 14"/>
+          <p:cNvSpPr/>
+          <p:nvPr/>
+        </p:nvSpPr>
+        <p:spPr>
+          <a:xfrm>
+            <a:off x="320040" y="4828032"/>
+            <a:ext cx="2121408" cy="36576"/>
+          </a:xfrm>
+          <a:prstGeom prst="rect">
+            <a:avLst/>
+          </a:prstGeom>
+          <a:solidFill>
+            <a:srgbClr val="E87D3E"/>
+          </a:solidFill>
+          <a:ln w="12700">
+            <a:solidFill>
+              <a:srgbClr val="FFFFFF"/>
+            </a:solidFill>
+            <a:prstDash val="solid"/>
+          </a:ln>
+        </p:spPr>
+      </p:sp>
+      <p:sp>
+        <p:nvSpPr>
+          <p:cNvPr id="20" name="Text 15"/>
+          <p:cNvSpPr/>
+          <p:nvPr/>
+        </p:nvSpPr>
+        <p:spPr>
+          <a:xfrm>
+            <a:off x="320040" y="4919472"/>
+            <a:ext cx="2121408" cy="960120"/>
+          </a:xfrm>
+          <a:prstGeom prst="rect">
+            <a:avLst/>
+          </a:prstGeom>
+          <a:noFill/>
+          <a:ln/>
+        </p:spPr>
+        <p:txBody>
+          <a:bodyPr wrap="square" rtlCol="0" anchor="ctr"/>
+          <a:lstStyle/>
+          <a:p>
+            <a:pPr indent="0" marL="0">
+              <a:buNone/>
+            </a:pPr>
+            <a:r>
+              <a:rPr lang="en-US" sz="1100" dirty="0">
+                <a:solidFill>
+                  <a:srgbClr val="FFFFFF"/>
+                </a:solidFill>
+                <a:latin typeface="Arial" pitchFamily="34" charset="0"/>
+                <a:ea typeface="Arial" pitchFamily="34" charset="-122"/>
+                <a:cs typeface="Arial" pitchFamily="34" charset="-120"/>
+              </a:rPr>
+              <a:t>22 kcal · 2g fiber per cup</a:t>
+            </a:r>
+            <a:endParaRPr lang="en-US" sz="1100" dirty="0"/>
+          </a:p>
+        </p:txBody>
+      </p:sp>
+      <p:pic>
+        <p:nvPicPr>
+          <p:cNvPr id="21" name="Image 3" descr="preencoded.png">    </p:cNvPr>
+          <p:cNvPicPr>
+            <a:picLocks noChangeAspect="1"/>
+          </p:cNvPicPr>
+          <p:nvPr/>
+        </p:nvPicPr>
+        <p:blipFill>
+          <a:blip r:embed="rId4"/>
+          <a:stretch>
+            <a:fillRect/>
+          </a:stretch>
+        </p:blipFill>
+        <p:spPr>
+          <a:xfrm>
+            <a:off x="2907792" y="4005072"/>
+            <a:ext cx="2395728" cy="2011680"/>
+          </a:xfrm>
+          <a:prstGeom prst="rect">
+            <a:avLst/>
+          </a:prstGeom>
+        </p:spPr>
+      </p:pic>
+      <p:sp>
+        <p:nvSpPr>
+          <p:cNvPr id="22" name="Shape 16"/>
+          <p:cNvSpPr/>
+          <p:nvPr/>
+        </p:nvSpPr>
+        <p:spPr>
+          <a:xfrm>
+            <a:off x="2907792" y="4005072"/>
+            <a:ext cx="2395728" cy="2011680"/>
+          </a:xfrm>
+          <a:prstGeom prst="rect">
+            <a:avLst/>
+          </a:prstGeom>
+          <a:solidFill>
+            <a:srgbClr val="000000">
+              <a:alpha val="65000"/>
+            </a:srgbClr>
+          </a:solidFill>
+          <a:ln w="12700">
+            <a:solidFill>
+              <a:srgbClr val="FFFFFF"/>
+            </a:solidFill>
+            <a:prstDash val="solid"/>
+          </a:ln>
+        </p:spPr>
+      </p:sp>
+      <p:sp>
+        <p:nvSpPr>
+          <p:cNvPr id="23" name="Text 17"/>
+          <p:cNvSpPr/>
+          <p:nvPr/>
+        </p:nvSpPr>
+        <p:spPr>
+          <a:xfrm>
+            <a:off x="3044952" y="4169664"/>
             <a:ext cx="2121408" cy="594360"/>
           </a:xfrm>
           <a:prstGeom prst="rect">
@@ -1994,13 +2226,13 @@
       </p:sp>
       <p:sp>
         <p:nvSpPr>
-          <p:cNvPr id="16" name="Shape 14"/>
-          <p:cNvSpPr/>
-          <p:nvPr/>
-        </p:nvSpPr>
-        <p:spPr>
-          <a:xfrm>
-            <a:off x="320040" y="4828032"/>
+          <p:cNvPr id="24" name="Shape 18"/>
+          <p:cNvSpPr/>
+          <p:nvPr/>
+        </p:nvSpPr>
+        <p:spPr>
+          <a:xfrm>
+            <a:off x="3044952" y="4828032"/>
             <a:ext cx="2121408" cy="36576"/>
           </a:xfrm>
           <a:prstGeom prst="rect">
@@ -2019,13 +2251,13 @@
       </p:sp>
       <p:sp>
         <p:nvSpPr>
-          <p:cNvPr id="17" name="Text 15"/>
-          <p:cNvSpPr/>
-          <p:nvPr/>
-        </p:nvSpPr>
-        <p:spPr>
-          <a:xfrm>
-            <a:off x="320040" y="4919472"/>
+          <p:cNvPr id="25" name="Text 19"/>
+          <p:cNvSpPr/>
+          <p:nvPr/>
+        </p:nvSpPr>
+        <p:spPr>
+          <a:xfrm>
+            <a:off x="3044952" y="4919472"/>
             <a:ext cx="2121408" cy="960120"/>
           </a:xfrm>
           <a:prstGeom prst="rect">
@@ -2050,7 +2282,7 @@
                 <a:ea typeface="Arial" pitchFamily="34" charset="-122"/>
                 <a:cs typeface="Arial" pitchFamily="34" charset="-120"/>
               </a:rPr>
-              <a:t>25 kcal · 2g fiber per 100g</a:t>
+              <a:t>27 kcal · 2g fiber per cup</a:t>
             </a:r>
             <a:endParaRPr lang="en-US" sz="1100" dirty="0"/>
           </a:p>
@@ -2058,135 +2290,7 @@
       </p:sp>
       <p:sp>
         <p:nvSpPr>
-          <p:cNvPr id="18" name="Shape 16"/>
-          <p:cNvSpPr/>
-          <p:nvPr/>
-        </p:nvSpPr>
-        <p:spPr>
-          <a:xfrm>
-            <a:off x="2907792" y="4005072"/>
-            <a:ext cx="2395728" cy="2011680"/>
-          </a:xfrm>
-          <a:prstGeom prst="rect">
-            <a:avLst/>
-          </a:prstGeom>
-          <a:solidFill>
-            <a:srgbClr val="5C5915"/>
-          </a:solidFill>
-          <a:ln w="12700">
-            <a:solidFill>
-              <a:srgbClr val="FFFFFF"/>
-            </a:solidFill>
-            <a:prstDash val="solid"/>
-          </a:ln>
-        </p:spPr>
-      </p:sp>
-      <p:sp>
-        <p:nvSpPr>
-          <p:cNvPr id="19" name="Text 17"/>
-          <p:cNvSpPr/>
-          <p:nvPr/>
-        </p:nvSpPr>
-        <p:spPr>
-          <a:xfrm>
-            <a:off x="3044952" y="4169664"/>
-            <a:ext cx="2121408" cy="594360"/>
-          </a:xfrm>
-          <a:prstGeom prst="rect">
-            <a:avLst/>
-          </a:prstGeom>
-          <a:noFill/>
-          <a:ln/>
-        </p:spPr>
-        <p:txBody>
-          <a:bodyPr wrap="square" rtlCol="0" anchor="ctr"/>
-          <a:lstStyle/>
-          <a:p>
-            <a:pPr indent="0" marL="0">
-              <a:buNone/>
-            </a:pPr>
-            <a:r>
-              <a:rPr lang="en-US" sz="1400" b="1" dirty="0">
-                <a:solidFill>
-                  <a:srgbClr val="FFFFFF"/>
-                </a:solidFill>
-                <a:latin typeface="Arial" pitchFamily="34" charset="0"/>
-                <a:ea typeface="Arial" pitchFamily="34" charset="-122"/>
-                <a:cs typeface="Arial" pitchFamily="34" charset="-120"/>
-              </a:rPr>
-              <a:t>Spinach</a:t>
-            </a:r>
-            <a:endParaRPr lang="en-US" sz="1400" dirty="0"/>
-          </a:p>
-        </p:txBody>
-      </p:sp>
-      <p:sp>
-        <p:nvSpPr>
-          <p:cNvPr id="20" name="Shape 18"/>
-          <p:cNvSpPr/>
-          <p:nvPr/>
-        </p:nvSpPr>
-        <p:spPr>
-          <a:xfrm>
-            <a:off x="3044952" y="4828032"/>
-            <a:ext cx="2121408" cy="36576"/>
-          </a:xfrm>
-          <a:prstGeom prst="rect">
-            <a:avLst/>
-          </a:prstGeom>
-          <a:solidFill>
-            <a:srgbClr val="E87D3E"/>
-          </a:solidFill>
-          <a:ln w="12700">
-            <a:solidFill>
-              <a:srgbClr val="FFFFFF"/>
-            </a:solidFill>
-            <a:prstDash val="solid"/>
-          </a:ln>
-        </p:spPr>
-      </p:sp>
-      <p:sp>
-        <p:nvSpPr>
-          <p:cNvPr id="21" name="Text 19"/>
-          <p:cNvSpPr/>
-          <p:nvPr/>
-        </p:nvSpPr>
-        <p:spPr>
-          <a:xfrm>
-            <a:off x="3044952" y="4919472"/>
-            <a:ext cx="2121408" cy="960120"/>
-          </a:xfrm>
-          <a:prstGeom prst="rect">
-            <a:avLst/>
-          </a:prstGeom>
-          <a:noFill/>
-          <a:ln/>
-        </p:spPr>
-        <p:txBody>
-          <a:bodyPr wrap="square" rtlCol="0" anchor="ctr"/>
-          <a:lstStyle/>
-          <a:p>
-            <a:pPr indent="0" marL="0">
-              <a:buNone/>
-            </a:pPr>
-            <a:r>
-              <a:rPr lang="en-US" sz="1100" dirty="0">
-                <a:solidFill>
-                  <a:srgbClr val="FFFFFF"/>
-                </a:solidFill>
-                <a:latin typeface="Arial" pitchFamily="34" charset="0"/>
-                <a:ea typeface="Arial" pitchFamily="34" charset="-122"/>
-                <a:cs typeface="Arial" pitchFamily="34" charset="-120"/>
-              </a:rPr>
-              <a:t>23 kcal · 2g fiber per 100g</a:t>
-            </a:r>
-            <a:endParaRPr lang="en-US" sz="1100" dirty="0"/>
-          </a:p>
-        </p:txBody>
-      </p:sp>
-      <p:sp>
-        <p:nvSpPr>
-          <p:cNvPr id="22" name="Text 20"/>
+          <p:cNvPr id="26" name="Text 20"/>
           <p:cNvSpPr/>
           <p:nvPr/>
         </p:nvSpPr>
@@ -2225,7 +2329,7 @@
       </p:sp>
       <p:sp>
         <p:nvSpPr>
-          <p:cNvPr id="23" name="Shape 21"/>
+          <p:cNvPr id="27" name="Shape 21"/>
           <p:cNvSpPr/>
           <p:nvPr/>
         </p:nvSpPr>
@@ -2250,7 +2354,7 @@
       </p:sp>
       <p:sp>
         <p:nvSpPr>
-          <p:cNvPr id="24" name="Text 22"/>
+          <p:cNvPr id="28" name="Text 22"/>
           <p:cNvSpPr/>
           <p:nvPr/>
         </p:nvSpPr>
@@ -2440,12 +2544,20 @@
           </a:p>
         </p:txBody>
       </p:sp>
-      <p:sp>
-        <p:nvSpPr>
-          <p:cNvPr id="6" name="Shape 4"/>
-          <p:cNvSpPr/>
-          <p:nvPr/>
-        </p:nvSpPr>
+      <p:pic>
+        <p:nvPicPr>
+          <p:cNvPr id="6" name="Image 0" descr="preencoded.png">    </p:cNvPr>
+          <p:cNvPicPr>
+            <a:picLocks noChangeAspect="1"/>
+          </p:cNvPicPr>
+          <p:nvPr/>
+        </p:nvPicPr>
+        <p:blipFill>
+          <a:blip r:embed="rId1"/>
+          <a:stretch>
+            <a:fillRect/>
+          </a:stretch>
+        </p:blipFill>
         <p:spPr>
           <a:xfrm>
             <a:off x="182880" y="1828800"/>
@@ -2454,8 +2566,26 @@
           <a:prstGeom prst="rect">
             <a:avLst/>
           </a:prstGeom>
-          <a:solidFill>
-            <a:srgbClr val="5C5915"/>
+        </p:spPr>
+      </p:pic>
+      <p:sp>
+        <p:nvSpPr>
+          <p:cNvPr id="7" name="Shape 4"/>
+          <p:cNvSpPr/>
+          <p:nvPr/>
+        </p:nvSpPr>
+        <p:spPr>
+          <a:xfrm>
+            <a:off x="182880" y="1828800"/>
+            <a:ext cx="2395728" cy="2011680"/>
+          </a:xfrm>
+          <a:prstGeom prst="rect">
+            <a:avLst/>
+          </a:prstGeom>
+          <a:solidFill>
+            <a:srgbClr val="000000">
+              <a:alpha val="65000"/>
+            </a:srgbClr>
           </a:solidFill>
           <a:ln w="12700">
             <a:solidFill>
@@ -2467,7 +2597,7 @@
       </p:sp>
       <p:sp>
         <p:nvSpPr>
-          <p:cNvPr id="7" name="Text 5"/>
+          <p:cNvPr id="8" name="Text 5"/>
           <p:cNvSpPr/>
           <p:nvPr/>
         </p:nvSpPr>
@@ -2506,7 +2636,7 @@
       </p:sp>
       <p:sp>
         <p:nvSpPr>
-          <p:cNvPr id="8" name="Shape 6"/>
+          <p:cNvPr id="9" name="Shape 6"/>
           <p:cNvSpPr/>
           <p:nvPr/>
         </p:nvSpPr>
@@ -2531,7 +2661,7 @@
       </p:sp>
       <p:sp>
         <p:nvSpPr>
-          <p:cNvPr id="9" name="Text 7"/>
+          <p:cNvPr id="10" name="Text 7"/>
           <p:cNvSpPr/>
           <p:nvPr/>
         </p:nvSpPr>
@@ -2568,12 +2698,20 @@
           </a:p>
         </p:txBody>
       </p:sp>
-      <p:sp>
-        <p:nvSpPr>
-          <p:cNvPr id="10" name="Shape 8"/>
-          <p:cNvSpPr/>
-          <p:nvPr/>
-        </p:nvSpPr>
+      <p:pic>
+        <p:nvPicPr>
+          <p:cNvPr id="11" name="Image 1" descr="preencoded.png">    </p:cNvPr>
+          <p:cNvPicPr>
+            <a:picLocks noChangeAspect="1"/>
+          </p:cNvPicPr>
+          <p:nvPr/>
+        </p:nvPicPr>
+        <p:blipFill>
+          <a:blip r:embed="rId2"/>
+          <a:stretch>
+            <a:fillRect/>
+          </a:stretch>
+        </p:blipFill>
         <p:spPr>
           <a:xfrm>
             <a:off x="2907792" y="1828800"/>
@@ -2582,8 +2720,26 @@
           <a:prstGeom prst="rect">
             <a:avLst/>
           </a:prstGeom>
-          <a:solidFill>
-            <a:srgbClr val="5C5915"/>
+        </p:spPr>
+      </p:pic>
+      <p:sp>
+        <p:nvSpPr>
+          <p:cNvPr id="12" name="Shape 8"/>
+          <p:cNvSpPr/>
+          <p:nvPr/>
+        </p:nvSpPr>
+        <p:spPr>
+          <a:xfrm>
+            <a:off x="2907792" y="1828800"/>
+            <a:ext cx="2395728" cy="2011680"/>
+          </a:xfrm>
+          <a:prstGeom prst="rect">
+            <a:avLst/>
+          </a:prstGeom>
+          <a:solidFill>
+            <a:srgbClr val="000000">
+              <a:alpha val="65000"/>
+            </a:srgbClr>
           </a:solidFill>
           <a:ln w="12700">
             <a:solidFill>
@@ -2595,7 +2751,7 @@
       </p:sp>
       <p:sp>
         <p:nvSpPr>
-          <p:cNvPr id="11" name="Text 9"/>
+          <p:cNvPr id="13" name="Text 9"/>
           <p:cNvSpPr/>
           <p:nvPr/>
         </p:nvSpPr>
@@ -2634,7 +2790,7 @@
       </p:sp>
       <p:sp>
         <p:nvSpPr>
-          <p:cNvPr id="12" name="Shape 10"/>
+          <p:cNvPr id="14" name="Shape 10"/>
           <p:cNvSpPr/>
           <p:nvPr/>
         </p:nvSpPr>
@@ -2659,7 +2815,7 @@
       </p:sp>
       <p:sp>
         <p:nvSpPr>
-          <p:cNvPr id="13" name="Text 11"/>
+          <p:cNvPr id="15" name="Text 11"/>
           <p:cNvSpPr/>
           <p:nvPr/>
         </p:nvSpPr>
@@ -2696,12 +2852,20 @@
           </a:p>
         </p:txBody>
       </p:sp>
-      <p:sp>
-        <p:nvSpPr>
-          <p:cNvPr id="14" name="Shape 12"/>
-          <p:cNvSpPr/>
-          <p:nvPr/>
-        </p:nvSpPr>
+      <p:pic>
+        <p:nvPicPr>
+          <p:cNvPr id="16" name="Image 2" descr="preencoded.png">    </p:cNvPr>
+          <p:cNvPicPr>
+            <a:picLocks noChangeAspect="1"/>
+          </p:cNvPicPr>
+          <p:nvPr/>
+        </p:nvPicPr>
+        <p:blipFill>
+          <a:blip r:embed="rId3"/>
+          <a:stretch>
+            <a:fillRect/>
+          </a:stretch>
+        </p:blipFill>
         <p:spPr>
           <a:xfrm>
             <a:off x="182880" y="4005072"/>
@@ -2710,8 +2874,26 @@
           <a:prstGeom prst="rect">
             <a:avLst/>
           </a:prstGeom>
-          <a:solidFill>
-            <a:srgbClr val="5C5915"/>
+        </p:spPr>
+      </p:pic>
+      <p:sp>
+        <p:nvSpPr>
+          <p:cNvPr id="17" name="Shape 12"/>
+          <p:cNvSpPr/>
+          <p:nvPr/>
+        </p:nvSpPr>
+        <p:spPr>
+          <a:xfrm>
+            <a:off x="182880" y="4005072"/>
+            <a:ext cx="2395728" cy="2011680"/>
+          </a:xfrm>
+          <a:prstGeom prst="rect">
+            <a:avLst/>
+          </a:prstGeom>
+          <a:solidFill>
+            <a:srgbClr val="000000">
+              <a:alpha val="65000"/>
+            </a:srgbClr>
           </a:solidFill>
           <a:ln w="12700">
             <a:solidFill>
@@ -2723,7 +2905,7 @@
       </p:sp>
       <p:sp>
         <p:nvSpPr>
-          <p:cNvPr id="15" name="Text 13"/>
+          <p:cNvPr id="18" name="Text 13"/>
           <p:cNvSpPr/>
           <p:nvPr/>
         </p:nvSpPr>
@@ -2762,7 +2944,7 @@
       </p:sp>
       <p:sp>
         <p:nvSpPr>
-          <p:cNvPr id="16" name="Shape 14"/>
+          <p:cNvPr id="19" name="Shape 14"/>
           <p:cNvSpPr/>
           <p:nvPr/>
         </p:nvSpPr>
@@ -2787,7 +2969,7 @@
       </p:sp>
       <p:sp>
         <p:nvSpPr>
-          <p:cNvPr id="17" name="Text 15"/>
+          <p:cNvPr id="20" name="Text 15"/>
           <p:cNvSpPr/>
           <p:nvPr/>
         </p:nvSpPr>
@@ -2824,12 +3006,20 @@
           </a:p>
         </p:txBody>
       </p:sp>
-      <p:sp>
-        <p:nvSpPr>
-          <p:cNvPr id="18" name="Shape 16"/>
-          <p:cNvSpPr/>
-          <p:nvPr/>
-        </p:nvSpPr>
+      <p:pic>
+        <p:nvPicPr>
+          <p:cNvPr id="21" name="Image 3" descr="preencoded.png">    </p:cNvPr>
+          <p:cNvPicPr>
+            <a:picLocks noChangeAspect="1"/>
+          </p:cNvPicPr>
+          <p:nvPr/>
+        </p:nvPicPr>
+        <p:blipFill>
+          <a:blip r:embed="rId4"/>
+          <a:stretch>
+            <a:fillRect/>
+          </a:stretch>
+        </p:blipFill>
         <p:spPr>
           <a:xfrm>
             <a:off x="2907792" y="4005072"/>
@@ -2838,8 +3028,26 @@
           <a:prstGeom prst="rect">
             <a:avLst/>
           </a:prstGeom>
-          <a:solidFill>
-            <a:srgbClr val="5C5915"/>
+        </p:spPr>
+      </p:pic>
+      <p:sp>
+        <p:nvSpPr>
+          <p:cNvPr id="22" name="Shape 16"/>
+          <p:cNvSpPr/>
+          <p:nvPr/>
+        </p:nvSpPr>
+        <p:spPr>
+          <a:xfrm>
+            <a:off x="2907792" y="4005072"/>
+            <a:ext cx="2395728" cy="2011680"/>
+          </a:xfrm>
+          <a:prstGeom prst="rect">
+            <a:avLst/>
+          </a:prstGeom>
+          <a:solidFill>
+            <a:srgbClr val="000000">
+              <a:alpha val="65000"/>
+            </a:srgbClr>
           </a:solidFill>
           <a:ln w="12700">
             <a:solidFill>
@@ -2851,7 +3059,7 @@
       </p:sp>
       <p:sp>
         <p:nvSpPr>
-          <p:cNvPr id="19" name="Text 17"/>
+          <p:cNvPr id="23" name="Text 17"/>
           <p:cNvSpPr/>
           <p:nvPr/>
         </p:nvSpPr>
@@ -2890,7 +3098,7 @@
       </p:sp>
       <p:sp>
         <p:nvSpPr>
-          <p:cNvPr id="20" name="Shape 18"/>
+          <p:cNvPr id="24" name="Shape 18"/>
           <p:cNvSpPr/>
           <p:nvPr/>
         </p:nvSpPr>
@@ -2915,7 +3123,7 @@
       </p:sp>
       <p:sp>
         <p:nvSpPr>
-          <p:cNvPr id="21" name="Text 19"/>
+          <p:cNvPr id="25" name="Text 19"/>
           <p:cNvSpPr/>
           <p:nvPr/>
         </p:nvSpPr>
@@ -2954,7 +3162,7 @@
       </p:sp>
       <p:sp>
         <p:nvSpPr>
-          <p:cNvPr id="22" name="Text 20"/>
+          <p:cNvPr id="26" name="Text 20"/>
           <p:cNvSpPr/>
           <p:nvPr/>
         </p:nvSpPr>
@@ -2993,7 +3201,7 @@
       </p:sp>
       <p:sp>
         <p:nvSpPr>
-          <p:cNvPr id="23" name="Shape 21"/>
+          <p:cNvPr id="27" name="Shape 21"/>
           <p:cNvSpPr/>
           <p:nvPr/>
         </p:nvSpPr>
@@ -3018,7 +3226,7 @@
       </p:sp>
       <p:sp>
         <p:nvSpPr>
-          <p:cNvPr id="24" name="Text 22"/>
+          <p:cNvPr id="28" name="Text 22"/>
           <p:cNvSpPr/>
           <p:nvPr/>
         </p:nvSpPr>
@@ -3208,12 +3416,20 @@
           </a:p>
         </p:txBody>
       </p:sp>
-      <p:sp>
-        <p:nvSpPr>
-          <p:cNvPr id="6" name="Shape 4"/>
-          <p:cNvSpPr/>
-          <p:nvPr/>
-        </p:nvSpPr>
+      <p:pic>
+        <p:nvPicPr>
+          <p:cNvPr id="6" name="Image 0" descr="preencoded.png">    </p:cNvPr>
+          <p:cNvPicPr>
+            <a:picLocks noChangeAspect="1"/>
+          </p:cNvPicPr>
+          <p:nvPr/>
+        </p:nvPicPr>
+        <p:blipFill>
+          <a:blip r:embed="rId1"/>
+          <a:stretch>
+            <a:fillRect/>
+          </a:stretch>
+        </p:blipFill>
         <p:spPr>
           <a:xfrm>
             <a:off x="182880" y="1828800"/>
@@ -3222,8 +3438,26 @@
           <a:prstGeom prst="rect">
             <a:avLst/>
           </a:prstGeom>
-          <a:solidFill>
-            <a:srgbClr val="5C5915"/>
+        </p:spPr>
+      </p:pic>
+      <p:sp>
+        <p:nvSpPr>
+          <p:cNvPr id="7" name="Shape 4"/>
+          <p:cNvSpPr/>
+          <p:nvPr/>
+        </p:nvSpPr>
+        <p:spPr>
+          <a:xfrm>
+            <a:off x="182880" y="1828800"/>
+            <a:ext cx="2395728" cy="2011680"/>
+          </a:xfrm>
+          <a:prstGeom prst="rect">
+            <a:avLst/>
+          </a:prstGeom>
+          <a:solidFill>
+            <a:srgbClr val="000000">
+              <a:alpha val="65000"/>
+            </a:srgbClr>
           </a:solidFill>
           <a:ln w="12700">
             <a:solidFill>
@@ -3235,7 +3469,7 @@
       </p:sp>
       <p:sp>
         <p:nvSpPr>
-          <p:cNvPr id="7" name="Text 5"/>
+          <p:cNvPr id="8" name="Text 5"/>
           <p:cNvSpPr/>
           <p:nvPr/>
         </p:nvSpPr>
@@ -3274,7 +3508,7 @@
       </p:sp>
       <p:sp>
         <p:nvSpPr>
-          <p:cNvPr id="8" name="Shape 6"/>
+          <p:cNvPr id="9" name="Shape 6"/>
           <p:cNvSpPr/>
           <p:nvPr/>
         </p:nvSpPr>
@@ -3299,7 +3533,7 @@
       </p:sp>
       <p:sp>
         <p:nvSpPr>
-          <p:cNvPr id="9" name="Text 7"/>
+          <p:cNvPr id="10" name="Text 7"/>
           <p:cNvSpPr/>
           <p:nvPr/>
         </p:nvSpPr>
@@ -3336,12 +3570,20 @@
           </a:p>
         </p:txBody>
       </p:sp>
-      <p:sp>
-        <p:nvSpPr>
-          <p:cNvPr id="10" name="Shape 8"/>
-          <p:cNvSpPr/>
-          <p:nvPr/>
-        </p:nvSpPr>
+      <p:pic>
+        <p:nvPicPr>
+          <p:cNvPr id="11" name="Image 1" descr="preencoded.png">    </p:cNvPr>
+          <p:cNvPicPr>
+            <a:picLocks noChangeAspect="1"/>
+          </p:cNvPicPr>
+          <p:nvPr/>
+        </p:nvPicPr>
+        <p:blipFill>
+          <a:blip r:embed="rId2"/>
+          <a:stretch>
+            <a:fillRect/>
+          </a:stretch>
+        </p:blipFill>
         <p:spPr>
           <a:xfrm>
             <a:off x="2907792" y="1828800"/>
@@ -3350,8 +3592,26 @@
           <a:prstGeom prst="rect">
             <a:avLst/>
           </a:prstGeom>
-          <a:solidFill>
-            <a:srgbClr val="5C5915"/>
+        </p:spPr>
+      </p:pic>
+      <p:sp>
+        <p:nvSpPr>
+          <p:cNvPr id="12" name="Shape 8"/>
+          <p:cNvSpPr/>
+          <p:nvPr/>
+        </p:nvSpPr>
+        <p:spPr>
+          <a:xfrm>
+            <a:off x="2907792" y="1828800"/>
+            <a:ext cx="2395728" cy="2011680"/>
+          </a:xfrm>
+          <a:prstGeom prst="rect">
+            <a:avLst/>
+          </a:prstGeom>
+          <a:solidFill>
+            <a:srgbClr val="000000">
+              <a:alpha val="65000"/>
+            </a:srgbClr>
           </a:solidFill>
           <a:ln w="12700">
             <a:solidFill>
@@ -3363,7 +3623,7 @@
       </p:sp>
       <p:sp>
         <p:nvSpPr>
-          <p:cNvPr id="11" name="Text 9"/>
+          <p:cNvPr id="13" name="Text 9"/>
           <p:cNvSpPr/>
           <p:nvPr/>
         </p:nvSpPr>
@@ -3402,7 +3662,7 @@
       </p:sp>
       <p:sp>
         <p:nvSpPr>
-          <p:cNvPr id="12" name="Shape 10"/>
+          <p:cNvPr id="14" name="Shape 10"/>
           <p:cNvSpPr/>
           <p:nvPr/>
         </p:nvSpPr>
@@ -3427,7 +3687,7 @@
       </p:sp>
       <p:sp>
         <p:nvSpPr>
-          <p:cNvPr id="13" name="Text 11"/>
+          <p:cNvPr id="15" name="Text 11"/>
           <p:cNvSpPr/>
           <p:nvPr/>
         </p:nvSpPr>
@@ -3464,12 +3724,20 @@
           </a:p>
         </p:txBody>
       </p:sp>
-      <p:sp>
-        <p:nvSpPr>
-          <p:cNvPr id="14" name="Shape 12"/>
-          <p:cNvSpPr/>
-          <p:nvPr/>
-        </p:nvSpPr>
+      <p:pic>
+        <p:nvPicPr>
+          <p:cNvPr id="16" name="Image 2" descr="preencoded.png">    </p:cNvPr>
+          <p:cNvPicPr>
+            <a:picLocks noChangeAspect="1"/>
+          </p:cNvPicPr>
+          <p:nvPr/>
+        </p:nvPicPr>
+        <p:blipFill>
+          <a:blip r:embed="rId3"/>
+          <a:stretch>
+            <a:fillRect/>
+          </a:stretch>
+        </p:blipFill>
         <p:spPr>
           <a:xfrm>
             <a:off x="182880" y="4005072"/>
@@ -3478,8 +3746,26 @@
           <a:prstGeom prst="rect">
             <a:avLst/>
           </a:prstGeom>
-          <a:solidFill>
-            <a:srgbClr val="5C5915"/>
+        </p:spPr>
+      </p:pic>
+      <p:sp>
+        <p:nvSpPr>
+          <p:cNvPr id="17" name="Shape 12"/>
+          <p:cNvSpPr/>
+          <p:nvPr/>
+        </p:nvSpPr>
+        <p:spPr>
+          <a:xfrm>
+            <a:off x="182880" y="4005072"/>
+            <a:ext cx="2395728" cy="2011680"/>
+          </a:xfrm>
+          <a:prstGeom prst="rect">
+            <a:avLst/>
+          </a:prstGeom>
+          <a:solidFill>
+            <a:srgbClr val="000000">
+              <a:alpha val="65000"/>
+            </a:srgbClr>
           </a:solidFill>
           <a:ln w="12700">
             <a:solidFill>
@@ -3491,7 +3777,7 @@
       </p:sp>
       <p:sp>
         <p:nvSpPr>
-          <p:cNvPr id="15" name="Text 13"/>
+          <p:cNvPr id="18" name="Text 13"/>
           <p:cNvSpPr/>
           <p:nvPr/>
         </p:nvSpPr>
@@ -3530,7 +3816,7 @@
       </p:sp>
       <p:sp>
         <p:nvSpPr>
-          <p:cNvPr id="16" name="Shape 14"/>
+          <p:cNvPr id="19" name="Shape 14"/>
           <p:cNvSpPr/>
           <p:nvPr/>
         </p:nvSpPr>
@@ -3555,7 +3841,7 @@
       </p:sp>
       <p:sp>
         <p:nvSpPr>
-          <p:cNvPr id="17" name="Text 15"/>
+          <p:cNvPr id="20" name="Text 15"/>
           <p:cNvSpPr/>
           <p:nvPr/>
         </p:nvSpPr>
@@ -3592,12 +3878,20 @@
           </a:p>
         </p:txBody>
       </p:sp>
-      <p:sp>
-        <p:nvSpPr>
-          <p:cNvPr id="18" name="Shape 16"/>
-          <p:cNvSpPr/>
-          <p:nvPr/>
-        </p:nvSpPr>
+      <p:pic>
+        <p:nvPicPr>
+          <p:cNvPr id="21" name="Image 3" descr="preencoded.png">    </p:cNvPr>
+          <p:cNvPicPr>
+            <a:picLocks noChangeAspect="1"/>
+          </p:cNvPicPr>
+          <p:nvPr/>
+        </p:nvPicPr>
+        <p:blipFill>
+          <a:blip r:embed="rId4"/>
+          <a:stretch>
+            <a:fillRect/>
+          </a:stretch>
+        </p:blipFill>
         <p:spPr>
           <a:xfrm>
             <a:off x="2907792" y="4005072"/>
@@ -3606,8 +3900,26 @@
           <a:prstGeom prst="rect">
             <a:avLst/>
           </a:prstGeom>
-          <a:solidFill>
-            <a:srgbClr val="5C5915"/>
+        </p:spPr>
+      </p:pic>
+      <p:sp>
+        <p:nvSpPr>
+          <p:cNvPr id="22" name="Shape 16"/>
+          <p:cNvSpPr/>
+          <p:nvPr/>
+        </p:nvSpPr>
+        <p:spPr>
+          <a:xfrm>
+            <a:off x="2907792" y="4005072"/>
+            <a:ext cx="2395728" cy="2011680"/>
+          </a:xfrm>
+          <a:prstGeom prst="rect">
+            <a:avLst/>
+          </a:prstGeom>
+          <a:solidFill>
+            <a:srgbClr val="000000">
+              <a:alpha val="65000"/>
+            </a:srgbClr>
           </a:solidFill>
           <a:ln w="12700">
             <a:solidFill>
@@ -3619,7 +3931,7 @@
       </p:sp>
       <p:sp>
         <p:nvSpPr>
-          <p:cNvPr id="19" name="Text 17"/>
+          <p:cNvPr id="23" name="Text 17"/>
           <p:cNvSpPr/>
           <p:nvPr/>
         </p:nvSpPr>
@@ -3658,7 +3970,7 @@
       </p:sp>
       <p:sp>
         <p:nvSpPr>
-          <p:cNvPr id="20" name="Shape 18"/>
+          <p:cNvPr id="24" name="Shape 18"/>
           <p:cNvSpPr/>
           <p:nvPr/>
         </p:nvSpPr>
@@ -3683,7 +3995,7 @@
       </p:sp>
       <p:sp>
         <p:nvSpPr>
-          <p:cNvPr id="21" name="Text 19"/>
+          <p:cNvPr id="25" name="Text 19"/>
           <p:cNvSpPr/>
           <p:nvPr/>
         </p:nvSpPr>
@@ -3722,7 +4034,7 @@
       </p:sp>
       <p:sp>
         <p:nvSpPr>
-          <p:cNvPr id="22" name="Text 20"/>
+          <p:cNvPr id="26" name="Text 20"/>
           <p:cNvSpPr/>
           <p:nvPr/>
         </p:nvSpPr>
@@ -3761,7 +4073,7 @@
       </p:sp>
       <p:sp>
         <p:nvSpPr>
-          <p:cNvPr id="23" name="Shape 21"/>
+          <p:cNvPr id="27" name="Shape 21"/>
           <p:cNvSpPr/>
           <p:nvPr/>
         </p:nvSpPr>
@@ -3786,7 +4098,7 @@
       </p:sp>
       <p:sp>
         <p:nvSpPr>
-          <p:cNvPr id="24" name="Text 22"/>
+          <p:cNvPr id="28" name="Text 22"/>
           <p:cNvSpPr/>
           <p:nvPr/>
         </p:nvSpPr>
@@ -3976,12 +4288,20 @@
           </a:p>
         </p:txBody>
       </p:sp>
-      <p:sp>
-        <p:nvSpPr>
-          <p:cNvPr id="6" name="Shape 4"/>
-          <p:cNvSpPr/>
-          <p:nvPr/>
-        </p:nvSpPr>
+      <p:pic>
+        <p:nvPicPr>
+          <p:cNvPr id="6" name="Image 0" descr="preencoded.png">    </p:cNvPr>
+          <p:cNvPicPr>
+            <a:picLocks noChangeAspect="1"/>
+          </p:cNvPicPr>
+          <p:nvPr/>
+        </p:nvPicPr>
+        <p:blipFill>
+          <a:blip r:embed="rId1"/>
+          <a:stretch>
+            <a:fillRect/>
+          </a:stretch>
+        </p:blipFill>
         <p:spPr>
           <a:xfrm>
             <a:off x="182880" y="1828800"/>
@@ -3990,8 +4310,26 @@
           <a:prstGeom prst="rect">
             <a:avLst/>
           </a:prstGeom>
-          <a:solidFill>
-            <a:srgbClr val="5C5915"/>
+        </p:spPr>
+      </p:pic>
+      <p:sp>
+        <p:nvSpPr>
+          <p:cNvPr id="7" name="Shape 4"/>
+          <p:cNvSpPr/>
+          <p:nvPr/>
+        </p:nvSpPr>
+        <p:spPr>
+          <a:xfrm>
+            <a:off x="182880" y="1828800"/>
+            <a:ext cx="2395728" cy="2011680"/>
+          </a:xfrm>
+          <a:prstGeom prst="rect">
+            <a:avLst/>
+          </a:prstGeom>
+          <a:solidFill>
+            <a:srgbClr val="000000">
+              <a:alpha val="65000"/>
+            </a:srgbClr>
           </a:solidFill>
           <a:ln w="12700">
             <a:solidFill>
@@ -4003,7 +4341,7 @@
       </p:sp>
       <p:sp>
         <p:nvSpPr>
-          <p:cNvPr id="7" name="Text 5"/>
+          <p:cNvPr id="8" name="Text 5"/>
           <p:cNvSpPr/>
           <p:nvPr/>
         </p:nvSpPr>
@@ -4042,7 +4380,7 @@
       </p:sp>
       <p:sp>
         <p:nvSpPr>
-          <p:cNvPr id="8" name="Shape 6"/>
+          <p:cNvPr id="9" name="Shape 6"/>
           <p:cNvSpPr/>
           <p:nvPr/>
         </p:nvSpPr>
@@ -4067,7 +4405,7 @@
       </p:sp>
       <p:sp>
         <p:nvSpPr>
-          <p:cNvPr id="9" name="Text 7"/>
+          <p:cNvPr id="10" name="Text 7"/>
           <p:cNvSpPr/>
           <p:nvPr/>
         </p:nvSpPr>
@@ -4098,18 +4436,26 @@
                 <a:ea typeface="Arial" pitchFamily="34" charset="-122"/>
                 <a:cs typeface="Arial" pitchFamily="34" charset="-120"/>
               </a:rPr>
-              <a:t>15 kcal · 96% water per 100g</a:t>
+              <a:t>16 kcal · 96% water per 100g</a:t>
             </a:r>
             <a:endParaRPr lang="en-US" sz="1100" dirty="0"/>
           </a:p>
         </p:txBody>
       </p:sp>
-      <p:sp>
-        <p:nvSpPr>
-          <p:cNvPr id="10" name="Shape 8"/>
-          <p:cNvSpPr/>
-          <p:nvPr/>
-        </p:nvSpPr>
+      <p:pic>
+        <p:nvPicPr>
+          <p:cNvPr id="11" name="Image 1" descr="preencoded.png">    </p:cNvPr>
+          <p:cNvPicPr>
+            <a:picLocks noChangeAspect="1"/>
+          </p:cNvPicPr>
+          <p:nvPr/>
+        </p:nvPicPr>
+        <p:blipFill>
+          <a:blip r:embed="rId2"/>
+          <a:stretch>
+            <a:fillRect/>
+          </a:stretch>
+        </p:blipFill>
         <p:spPr>
           <a:xfrm>
             <a:off x="2907792" y="1828800"/>
@@ -4118,8 +4464,26 @@
           <a:prstGeom prst="rect">
             <a:avLst/>
           </a:prstGeom>
-          <a:solidFill>
-            <a:srgbClr val="5C5915"/>
+        </p:spPr>
+      </p:pic>
+      <p:sp>
+        <p:nvSpPr>
+          <p:cNvPr id="12" name="Shape 8"/>
+          <p:cNvSpPr/>
+          <p:nvPr/>
+        </p:nvSpPr>
+        <p:spPr>
+          <a:xfrm>
+            <a:off x="2907792" y="1828800"/>
+            <a:ext cx="2395728" cy="2011680"/>
+          </a:xfrm>
+          <a:prstGeom prst="rect">
+            <a:avLst/>
+          </a:prstGeom>
+          <a:solidFill>
+            <a:srgbClr val="000000">
+              <a:alpha val="65000"/>
+            </a:srgbClr>
           </a:solidFill>
           <a:ln w="12700">
             <a:solidFill>
@@ -4131,7 +4495,7 @@
       </p:sp>
       <p:sp>
         <p:nvSpPr>
-          <p:cNvPr id="11" name="Text 9"/>
+          <p:cNvPr id="13" name="Text 9"/>
           <p:cNvSpPr/>
           <p:nvPr/>
         </p:nvSpPr>
@@ -4170,7 +4534,7 @@
       </p:sp>
       <p:sp>
         <p:nvSpPr>
-          <p:cNvPr id="12" name="Shape 10"/>
+          <p:cNvPr id="14" name="Shape 10"/>
           <p:cNvSpPr/>
           <p:nvPr/>
         </p:nvSpPr>
@@ -4195,7 +4559,7 @@
       </p:sp>
       <p:sp>
         <p:nvSpPr>
-          <p:cNvPr id="13" name="Text 11"/>
+          <p:cNvPr id="15" name="Text 11"/>
           <p:cNvSpPr/>
           <p:nvPr/>
         </p:nvSpPr>
@@ -4232,12 +4596,20 @@
           </a:p>
         </p:txBody>
       </p:sp>
-      <p:sp>
-        <p:nvSpPr>
-          <p:cNvPr id="14" name="Shape 12"/>
-          <p:cNvSpPr/>
-          <p:nvPr/>
-        </p:nvSpPr>
+      <p:pic>
+        <p:nvPicPr>
+          <p:cNvPr id="16" name="Image 2" descr="preencoded.png">    </p:cNvPr>
+          <p:cNvPicPr>
+            <a:picLocks noChangeAspect="1"/>
+          </p:cNvPicPr>
+          <p:nvPr/>
+        </p:nvPicPr>
+        <p:blipFill>
+          <a:blip r:embed="rId3"/>
+          <a:stretch>
+            <a:fillRect/>
+          </a:stretch>
+        </p:blipFill>
         <p:spPr>
           <a:xfrm>
             <a:off x="182880" y="4005072"/>
@@ -4246,8 +4618,26 @@
           <a:prstGeom prst="rect">
             <a:avLst/>
           </a:prstGeom>
-          <a:solidFill>
-            <a:srgbClr val="5C5915"/>
+        </p:spPr>
+      </p:pic>
+      <p:sp>
+        <p:nvSpPr>
+          <p:cNvPr id="17" name="Shape 12"/>
+          <p:cNvSpPr/>
+          <p:nvPr/>
+        </p:nvSpPr>
+        <p:spPr>
+          <a:xfrm>
+            <a:off x="182880" y="4005072"/>
+            <a:ext cx="2395728" cy="2011680"/>
+          </a:xfrm>
+          <a:prstGeom prst="rect">
+            <a:avLst/>
+          </a:prstGeom>
+          <a:solidFill>
+            <a:srgbClr val="000000">
+              <a:alpha val="65000"/>
+            </a:srgbClr>
           </a:solidFill>
           <a:ln w="12700">
             <a:solidFill>
@@ -4259,7 +4649,7 @@
       </p:sp>
       <p:sp>
         <p:nvSpPr>
-          <p:cNvPr id="15" name="Text 13"/>
+          <p:cNvPr id="18" name="Text 13"/>
           <p:cNvSpPr/>
           <p:nvPr/>
         </p:nvSpPr>
@@ -4298,7 +4688,7 @@
       </p:sp>
       <p:sp>
         <p:nvSpPr>
-          <p:cNvPr id="16" name="Shape 14"/>
+          <p:cNvPr id="19" name="Shape 14"/>
           <p:cNvSpPr/>
           <p:nvPr/>
         </p:nvSpPr>
@@ -4323,7 +4713,7 @@
       </p:sp>
       <p:sp>
         <p:nvSpPr>
-          <p:cNvPr id="17" name="Text 15"/>
+          <p:cNvPr id="20" name="Text 15"/>
           <p:cNvSpPr/>
           <p:nvPr/>
         </p:nvSpPr>
@@ -4360,12 +4750,20 @@
           </a:p>
         </p:txBody>
       </p:sp>
-      <p:sp>
-        <p:nvSpPr>
-          <p:cNvPr id="18" name="Shape 16"/>
-          <p:cNvSpPr/>
-          <p:nvPr/>
-        </p:nvSpPr>
+      <p:pic>
+        <p:nvPicPr>
+          <p:cNvPr id="21" name="Image 3" descr="preencoded.png">    </p:cNvPr>
+          <p:cNvPicPr>
+            <a:picLocks noChangeAspect="1"/>
+          </p:cNvPicPr>
+          <p:nvPr/>
+        </p:nvPicPr>
+        <p:blipFill>
+          <a:blip r:embed="rId4"/>
+          <a:stretch>
+            <a:fillRect/>
+          </a:stretch>
+        </p:blipFill>
         <p:spPr>
           <a:xfrm>
             <a:off x="2907792" y="4005072"/>
@@ -4374,8 +4772,26 @@
           <a:prstGeom prst="rect">
             <a:avLst/>
           </a:prstGeom>
-          <a:solidFill>
-            <a:srgbClr val="5C5915"/>
+        </p:spPr>
+      </p:pic>
+      <p:sp>
+        <p:nvSpPr>
+          <p:cNvPr id="22" name="Shape 16"/>
+          <p:cNvSpPr/>
+          <p:nvPr/>
+        </p:nvSpPr>
+        <p:spPr>
+          <a:xfrm>
+            <a:off x="2907792" y="4005072"/>
+            <a:ext cx="2395728" cy="2011680"/>
+          </a:xfrm>
+          <a:prstGeom prst="rect">
+            <a:avLst/>
+          </a:prstGeom>
+          <a:solidFill>
+            <a:srgbClr val="000000">
+              <a:alpha val="65000"/>
+            </a:srgbClr>
           </a:solidFill>
           <a:ln w="12700">
             <a:solidFill>
@@ -4387,7 +4803,7 @@
       </p:sp>
       <p:sp>
         <p:nvSpPr>
-          <p:cNvPr id="19" name="Text 17"/>
+          <p:cNvPr id="23" name="Text 17"/>
           <p:cNvSpPr/>
           <p:nvPr/>
         </p:nvSpPr>
@@ -4426,7 +4842,7 @@
       </p:sp>
       <p:sp>
         <p:nvSpPr>
-          <p:cNvPr id="20" name="Shape 18"/>
+          <p:cNvPr id="24" name="Shape 18"/>
           <p:cNvSpPr/>
           <p:nvPr/>
         </p:nvSpPr>
@@ -4451,7 +4867,7 @@
       </p:sp>
       <p:sp>
         <p:nvSpPr>
-          <p:cNvPr id="21" name="Text 19"/>
+          <p:cNvPr id="25" name="Text 19"/>
           <p:cNvSpPr/>
           <p:nvPr/>
         </p:nvSpPr>
@@ -4490,7 +4906,7 @@
       </p:sp>
       <p:sp>
         <p:nvSpPr>
-          <p:cNvPr id="22" name="Text 20"/>
+          <p:cNvPr id="26" name="Text 20"/>
           <p:cNvSpPr/>
           <p:nvPr/>
         </p:nvSpPr>
@@ -4529,7 +4945,7 @@
       </p:sp>
       <p:sp>
         <p:nvSpPr>
-          <p:cNvPr id="23" name="Shape 21"/>
+          <p:cNvPr id="27" name="Shape 21"/>
           <p:cNvSpPr/>
           <p:nvPr/>
         </p:nvSpPr>
@@ -4554,7 +4970,7 @@
       </p:sp>
       <p:sp>
         <p:nvSpPr>
-          <p:cNvPr id="24" name="Text 22"/>
+          <p:cNvPr id="28" name="Text 22"/>
           <p:cNvSpPr/>
           <p:nvPr/>
         </p:nvSpPr>

</xml_diff>